<commit_message>
feat: harden AgentTeams finals candidate
</commit_message>
<xml_diff>
--- a/outputs/DevFlow_GOAI_2026_决赛路演_20260728.pptx
+++ b/outputs/DevFlow_GOAI_2026_决赛路演_20260728.pptx
@@ -2,24 +2,24 @@
 <file path=ppt/presentation.xml><?xml version="1.0" encoding="utf-8"?>
 <p:presentation xmlns:p="http://schemas.openxmlformats.org/presentationml/2006/main">
   <p:sldMasterIdLst>
-    <p:sldMasterId xmlns:r="http://schemas.openxmlformats.org/officeDocument/2006/relationships" id="2147483648" r:id="Race971234df44637"/>
+    <p:sldMasterId xmlns:r="http://schemas.openxmlformats.org/officeDocument/2006/relationships" id="2147483648" r:id="R60d0795daea748b3"/>
   </p:sldMasterIdLst>
   <p:notesMasterIdLst>
-    <p:notesMasterId xmlns:r="http://schemas.openxmlformats.org/officeDocument/2006/relationships" r:id="R2a3de3b80dea4597"/>
+    <p:notesMasterId xmlns:r="http://schemas.openxmlformats.org/officeDocument/2006/relationships" r:id="Reb84fd31ab294cc3"/>
   </p:notesMasterIdLst>
   <p:sldIdLst>
-    <p:sldId xmlns:r="http://schemas.openxmlformats.org/officeDocument/2006/relationships" id="256" r:id="R3d4497c4cf2d4be7"/>
-    <p:sldId xmlns:r="http://schemas.openxmlformats.org/officeDocument/2006/relationships" id="257" r:id="R05d699e618b74331"/>
-    <p:sldId xmlns:r="http://schemas.openxmlformats.org/officeDocument/2006/relationships" id="258" r:id="Rbda752b430594c1f"/>
-    <p:sldId xmlns:r="http://schemas.openxmlformats.org/officeDocument/2006/relationships" id="259" r:id="R9c7d14679d3a4fee"/>
-    <p:sldId xmlns:r="http://schemas.openxmlformats.org/officeDocument/2006/relationships" id="260" r:id="Rafd87888b3584b7a"/>
-    <p:sldId xmlns:r="http://schemas.openxmlformats.org/officeDocument/2006/relationships" id="261" r:id="R97169a5c359f4bba"/>
-    <p:sldId xmlns:r="http://schemas.openxmlformats.org/officeDocument/2006/relationships" id="262" r:id="R4b16c19452f943e8"/>
-    <p:sldId xmlns:r="http://schemas.openxmlformats.org/officeDocument/2006/relationships" id="263" r:id="R359591756ed045c1"/>
-    <p:sldId xmlns:r="http://schemas.openxmlformats.org/officeDocument/2006/relationships" id="264" r:id="R34b3eb7a8c03490d"/>
-    <p:sldId xmlns:r="http://schemas.openxmlformats.org/officeDocument/2006/relationships" id="265" r:id="R951838570ba346e3"/>
-    <p:sldId xmlns:r="http://schemas.openxmlformats.org/officeDocument/2006/relationships" id="266" r:id="Rd5394e8799384ae3"/>
-    <p:sldId xmlns:r="http://schemas.openxmlformats.org/officeDocument/2006/relationships" id="267" r:id="Rb0884517f3a24c48"/>
+    <p:sldId xmlns:r="http://schemas.openxmlformats.org/officeDocument/2006/relationships" id="256" r:id="Rc0f555f3f858459f"/>
+    <p:sldId xmlns:r="http://schemas.openxmlformats.org/officeDocument/2006/relationships" id="257" r:id="Re99bfc00308042ab"/>
+    <p:sldId xmlns:r="http://schemas.openxmlformats.org/officeDocument/2006/relationships" id="258" r:id="R226c4dfadf7a4c0a"/>
+    <p:sldId xmlns:r="http://schemas.openxmlformats.org/officeDocument/2006/relationships" id="259" r:id="Rf04d5a81dd614dd7"/>
+    <p:sldId xmlns:r="http://schemas.openxmlformats.org/officeDocument/2006/relationships" id="260" r:id="R7375e1d2a2d04072"/>
+    <p:sldId xmlns:r="http://schemas.openxmlformats.org/officeDocument/2006/relationships" id="261" r:id="R2a2f50aa97694eb3"/>
+    <p:sldId xmlns:r="http://schemas.openxmlformats.org/officeDocument/2006/relationships" id="262" r:id="R8d3cfb0174754269"/>
+    <p:sldId xmlns:r="http://schemas.openxmlformats.org/officeDocument/2006/relationships" id="263" r:id="R54f85c103c79404c"/>
+    <p:sldId xmlns:r="http://schemas.openxmlformats.org/officeDocument/2006/relationships" id="264" r:id="R5ea745d18a8c43c9"/>
+    <p:sldId xmlns:r="http://schemas.openxmlformats.org/officeDocument/2006/relationships" id="265" r:id="R4ef5b498d4764e05"/>
+    <p:sldId xmlns:r="http://schemas.openxmlformats.org/officeDocument/2006/relationships" id="266" r:id="R6df31b1155f54c40"/>
+    <p:sldId xmlns:r="http://schemas.openxmlformats.org/officeDocument/2006/relationships" id="267" r:id="R0e9979946cc54aeb"/>
   </p:sldIdLst>
   <p:sldSz cx="12192000" cy="6858000"/>
   <p:notesSz cx="6858000" cy="9144000"/>
@@ -1173,7 +1173,7 @@
           <a:lstStyle xmlns:a="http://schemas.openxmlformats.org/drawingml/2006/main"/>
           <a:p xmlns:a="http://schemas.openxmlformats.org/drawingml/2006/main">
             <a:r>
-              <a:t>MCP 不靠提示词保护。Leader、Locator、Higress、Broker、GitHub API 每层都校验不同边界；错路径、错租户、错身份、直连、过期与重放都 fail closed。</a:t>
+              <a:t>MCP 不靠提示词保护。2026-07-27/28 历史现场验证固定 scope 的错路径、错身份与直连拒绝；错租户、过期和冲突重放另有本地测试。不同证据层不拼接为当前任意仓库 E2E。</a:t>
             </a:r>
           </a:p>
           <a:p xmlns:a="http://schemas.openxmlformats.org/drawingml/2006/main">
@@ -1263,7 +1263,7 @@
           <a:lstStyle xmlns:a="http://schemas.openxmlformats.org/drawingml/2006/main"/>
           <a:p xmlns:a="http://schemas.openxmlformats.org/drawingml/2006/main">
             <a:r>
-              <a:t>每个 Skill 是版本化资产：合同、触发/拒绝条件、依赖失败、安全边界、正反例与独立验证器齐全。测试证据要签名，经验只从 VERIFIED 终态进入。</a:t>
+              <a:t>每个 Skill 是版本化资产：合同、触发/拒绝条件、依赖失败、安全边界、正反例与独立验证器齐全。便携 profile 只生成摘要绑定自证明；AgentTeams 独立 CI 仍是候选。当前 Leader Pod 内完全相同的 JTI 与接受请求/结果绑定幂等读回，冲突绑定拒绝，不确定权威状态保持 pending 并 fail closed；ledger 不跨 Pod replacement，回执 120 秒过期。经验只从 VERIFIED 终态进入。</a:t>
             </a:r>
           </a:p>
           <a:p xmlns:a="http://schemas.openxmlformats.org/drawingml/2006/main">
@@ -1273,22 +1273,22 @@
           </a:p>
           <a:p xmlns:a="http://schemas.openxmlformats.org/drawingml/2006/main">
             <a:r>
-              <a:t>- skills/</a:t>
-            </a:r>
-          </a:p>
-          <a:p xmlns:a="http://schemas.openxmlformats.org/drawingml/2006/main">
-            <a:r>
-              <a:t>- evals/skill_behavior/cases.yaml</a:t>
-            </a:r>
-          </a:p>
-          <a:p xmlns:a="http://schemas.openxmlformats.org/drawingml/2006/main">
-            <a:r>
-              <a:t>- src/devflow/skills/catalog.py</a:t>
-            </a:r>
-          </a:p>
-          <a:p xmlns:a="http://schemas.openxmlformats.org/drawingml/2006/main">
-            <a:r>
-              <a:t>- tests/test_skill_validator_standalone.py</a:t>
+              <a:t>- skills/test-runner/</a:t>
+            </a:r>
+          </a:p>
+          <a:p xmlns:a="http://schemas.openxmlformats.org/drawingml/2006/main">
+            <a:r>
+              <a:t>- agentteams/cicd/tester_server.py</a:t>
+            </a:r>
+          </a:p>
+          <a:p xmlns:a="http://schemas.openxmlformats.org/drawingml/2006/main">
+            <a:r>
+              <a:t>- agentteams/teamharness/guarded_server.py</a:t>
+            </a:r>
+          </a:p>
+          <a:p xmlns:a="http://schemas.openxmlformats.org/drawingml/2006/main">
+            <a:r>
+              <a:t>- tests/test_teamharness_test_execution_receipt.py</a:t>
             </a:r>
           </a:p>
         </p:txBody>
@@ -1536,7 +1536,7 @@
   </p:cSld>
   <p:clrMap bg1="lt1" tx1="dk1" bg2="lt2" tx2="dk2" accent1="accent1" accent2="accent2" accent3="accent3" accent4="accent4" accent5="accent5" accent6="accent6" hlink="hlink" folHlink="folHlink"/>
   <p:sldLayoutIdLst>
-    <p:sldLayoutId xmlns:r="http://schemas.openxmlformats.org/officeDocument/2006/relationships" id="2147483649" r:id="R7735f3aa6bdf4672"/>
+    <p:sldLayoutId xmlns:r="http://schemas.openxmlformats.org/officeDocument/2006/relationships" id="2147483649" r:id="R1ca63198866d4c96"/>
   </p:sldLayoutIdLst>
   <p:txStyles>
     <p:titleStyle>
@@ -2903,7 +2903,7 @@
                 <a:ea typeface="Noto Sans SC"/>
                 <a:cs typeface="Noto Sans SC"/>
               </a:rPr>
-              <a:t>决赛现场只演三条链：成功、失败、人工批准</a:t>
+              <a:t>决赛目标三条链：未放行的不标 LIVE</a:t>
             </a:r>
           </a:p>
         </p:txBody>
@@ -3258,7 +3258,7 @@
                 <a:ea typeface="Noto Sans SC"/>
                 <a:cs typeface="Noto Sans SC"/>
               </a:rPr>
-              <a:t>红测只回 Coder</a:t>
+              <a:t>目标｜红测只回 Coder</a:t>
             </a:r>
           </a:p>
           <a:p xmlns:a="http://schemas.openxmlformats.org/drawingml/2006/main">
@@ -3354,7 +3354,7 @@
                 <a:ea typeface="Noto Sans SC"/>
                 <a:cs typeface="Noto Sans SC"/>
               </a:rPr>
-              <a:t>同一 task 完整闭环</a:t>
+              <a:t>目标｜同一 task 完整闭环</a:t>
             </a:r>
           </a:p>
           <a:p xmlns:a="http://schemas.openxmlformats.org/drawingml/2006/main">
@@ -3450,7 +3450,7 @@
                 <a:ea typeface="Noto Sans SC"/>
                 <a:cs typeface="Noto Sans SC"/>
               </a:rPr>
-              <a:t>先拒绝，再恢复</a:t>
+              <a:t>目标｜先拒绝，再恢复</a:t>
             </a:r>
           </a:p>
           <a:p xmlns:a="http://schemas.openxmlformats.org/drawingml/2006/main">
@@ -3632,7 +3632,7 @@
                 <a:ea typeface="Noto Sans SC"/>
                 <a:cs typeface="Noto Sans SC"/>
               </a:rPr>
-              <a:t>本地已验｜六阶段 / CI / 审计 / T4</a:t>
+              <a:t>本地｜离线六阶段 / portable 测试 / T4 测试</a:t>
             </a:r>
           </a:p>
           <a:p xmlns:a="http://schemas.openxmlformats.org/drawingml/2006/main">
@@ -3665,7 +3665,7 @@
                 <a:ea typeface="Noto Sans SC"/>
                 <a:cs typeface="Noto Sans SC"/>
               </a:rPr>
-              <a:t>现场已验｜两节点 / GitHub 只读边界</a:t>
+              <a:t>候选 / 历史｜v2.1 与 CI 合同 / 两节点与 GitHub 边界</a:t>
             </a:r>
           </a:p>
           <a:p xmlns:a="http://schemas.openxmlformats.org/drawingml/2006/main">
@@ -3698,7 +3698,7 @@
                 <a:ea typeface="Noto Sans SC"/>
                 <a:cs typeface="Noto Sans SC"/>
               </a:rPr>
-              <a:t>待补录｜集群闭环 / 真人批准 / 三仓基准</a:t>
+              <a:t>待服｜集群闭环 / 真人批准 / 三仓</a:t>
             </a:r>
           </a:p>
         </p:txBody>
@@ -4721,7 +4721,7 @@
                 <a:ea typeface="Noto Sans SC"/>
                 <a:cs typeface="Noto Sans SC"/>
               </a:rPr>
-              <a:t>隔离副本跑预注册 CI，签名测试证据；不改 canonical。</a:t>
+              <a:t>隔离副本跑预注册 CI，摘要绑定证据；不改 canonical。</a:t>
             </a:r>
           </a:p>
         </p:txBody>
@@ -5009,7 +5009,7 @@
                 <a:ea typeface="Noto Sans SC"/>
                 <a:cs typeface="Noto Sans SC"/>
               </a:rPr>
-              <a:t>安全 &gt; 外部批准 &gt; 签名测试 &gt; 审查 &gt; Coder 自检。</a:t>
+              <a:t>安全 &gt; 外部批准 &gt; 完整性证据 &gt; 审查 &gt; Coder 自检。</a:t>
             </a:r>
           </a:p>
         </p:txBody>
@@ -6212,7 +6212,7 @@
                 <a:ea typeface="Noto Sans SC"/>
                 <a:cs typeface="Noto Sans SC"/>
               </a:rPr>
-              <a:t>03 上下文 / 04 执行</a:t>
+              <a:t>03/04 协同</a:t>
             </a:r>
           </a:p>
         </p:txBody>
@@ -6873,7 +6873,7 @@
                 <a:ea typeface="Noto Sans SC"/>
                 <a:cs typeface="Noto Sans SC"/>
               </a:rPr>
-              <a:t>Broker：复核 token、Agent/Skill 与精确 scope</a:t>
+              <a:t>Issuer / Broker：验身份与 scope，签发并复核短期 capability</a:t>
             </a:r>
           </a:p>
         </p:txBody>
@@ -7333,7 +7333,7 @@
                 <a:ea typeface="Noto Sans SC"/>
                 <a:cs typeface="Noto Sans SC"/>
               </a:rPr>
-              <a:t>Leader：签发 tenant / repo / revision / path</a:t>
+              <a:t>Leader：固定 assignment scope，不签发凭据</a:t>
             </a:r>
           </a:p>
         </p:txBody>
@@ -7558,7 +7558,7 @@
                 <a:ea typeface="Noto Sans SC"/>
                 <a:cs typeface="Noto Sans SC"/>
               </a:rPr>
-              <a:t>Tester｜隔离基线→候选；签名 attestation → TestEvidence</a:t>
+              <a:t>Tester｜候选独立 CI 合同；待服务器实跑</a:t>
             </a:r>
           </a:p>
         </p:txBody>
@@ -8446,7 +8446,7 @@
                 <a:ea typeface="Noto Sans SC"/>
                 <a:cs typeface="Noto Sans SC"/>
               </a:rPr>
-              <a:t>离线 Demo 不是预制 JSON：六阶段、真实测试、持久审计</a:t>
+              <a:t>本地已验：离线六阶段、真实副本测试、SQLite 审计</a:t>
             </a:r>
           </a:p>
         </p:txBody>
@@ -8593,9 +8593,9 @@
                 <a:ea typeface="Noto Sans SC"/>
                 <a:cs typeface="Noto Sans SC"/>
               </a:rPr>
-              <a:t>Skill 包</a:t>
-            </a:r>
-            <a:br>
+              <a:t>1,330 passed / 24 skipped</a:t>
+            </a:r>
+            <a:r>
               <a:rPr sz="1400" b="1">
                 <a:solidFill>
                   <a:srgbClr val="000000"/>
@@ -8604,17 +8604,8 @@
                 <a:ea typeface="Noto Sans SC"/>
                 <a:cs typeface="Noto Sans SC"/>
               </a:rPr>
-            </a:br>
-            <a:r>
-              <a:rPr sz="1400" b="1">
-                <a:solidFill>
-                  <a:srgbClr val="000000"/>
-                </a:solidFill>
-                <a:latin typeface="Noto Sans SC"/>
-                <a:ea typeface="Noto Sans SC"/>
-                <a:cs typeface="Noto Sans SC"/>
-              </a:rPr>
-              <a:t>独立验证器全部通过</a:t>
+              <a:t>
+7/7 Skill 静态 100/100</a:t>
             </a:r>
           </a:p>
         </p:txBody>
@@ -8887,7 +8878,7 @@
                 <a:ea typeface="Noto Sans SC"/>
                 <a:cs typeface="Noto Sans SC"/>
               </a:rPr>
-              <a:t>7/7</a:t>
+              <a:t>84.06%</a:t>
             </a:r>
           </a:p>
         </p:txBody>
@@ -8983,7 +8974,7 @@
                 <a:ea typeface="Noto Sans SC"/>
                 <a:cs typeface="Noto Sans SC"/>
               </a:rPr>
-              <a:t>同一 task 走六个阶段路由：隔离 CI、SQLite 路由账本、跨进程租约、哈希审计链均真实执行。它只证明本地状态机与边界可复跑；不冒充集群现场或仓库修复成功率。</a:t>
+              <a:t>同一 task 走六阶段路由；临时副本测试、SQLite 路由账本、跨进程租约和哈希链真实执行。独立 AgentTeams CI Pod 仍待服务器实跑；本地证据不冒充集群或仓库修复成功率。</a:t>
             </a:r>
           </a:p>
         </p:txBody>
@@ -10105,7 +10096,7 @@
                           <a:ea typeface="Noto Sans SC"/>
                           <a:cs typeface="Noto Sans SC"/>
                         </a:rPr>
-                        <a:t>真实现场</a:t>
+                        <a:t>历史现场</a:t>
                       </a:r>
                     </a:p>
                   </a:txBody>
@@ -10201,7 +10192,7 @@
                           <a:ea typeface="Noto Sans SC"/>
                           <a:cs typeface="Noto Sans SC"/>
                         </a:rPr>
-                        <a:t>目前仅两节点</a:t>
+                        <a:t>2026-07-27/28，仅两节点</a:t>
                       </a:r>
                     </a:p>
                   </a:txBody>
@@ -10267,7 +10258,7 @@
                           <a:ea typeface="Noto Sans SC"/>
                           <a:cs typeface="Noto Sans SC"/>
                         </a:rPr>
-                        <a:t>真实现场</a:t>
+                        <a:t>历史现场</a:t>
                       </a:r>
                     </a:p>
                   </a:txBody>
@@ -10363,7 +10354,7 @@
                           <a:ea typeface="Noto Sans SC"/>
                           <a:cs typeface="Noto Sans SC"/>
                         </a:rPr>
-                        <a:t>只读单范围</a:t>
+                        <a:t>2026-07-27/28，只读单范围</a:t>
                       </a:r>
                     </a:p>
                   </a:txBody>

</xml_diff>